<commit_message>
feat: establish shared text layout system
</commit_message>
<xml_diff>
--- a/assets/结构图/循环闭环-001/example.pptx
+++ b/assets/结构图/循环闭环-001/example.pptx
@@ -2,13 +2,13 @@
 <file path=ppt/presentation.xml><?xml version="1.0" encoding="utf-8"?>
 <p:presentation xmlns:p="http://schemas.openxmlformats.org/presentationml/2006/main">
   <p:sldMasterIdLst>
-    <p:sldMasterId xmlns:r="http://schemas.openxmlformats.org/officeDocument/2006/relationships" id="2147483648" r:id="R5f60d286a795419a"/>
+    <p:sldMasterId xmlns:r="http://schemas.openxmlformats.org/officeDocument/2006/relationships" id="2147483648" r:id="Rdd79074e25d54155"/>
   </p:sldMasterIdLst>
   <p:notesMasterIdLst>
-    <p:notesMasterId xmlns:r="http://schemas.openxmlformats.org/officeDocument/2006/relationships" r:id="R3ac2a9ef4e5049ff"/>
+    <p:notesMasterId xmlns:r="http://schemas.openxmlformats.org/officeDocument/2006/relationships" r:id="R8b258e1b7e344c47"/>
   </p:notesMasterIdLst>
   <p:sldIdLst>
-    <p:sldId xmlns:r="http://schemas.openxmlformats.org/officeDocument/2006/relationships" id="256" r:id="Rfb65384e3045481a"/>
+    <p:sldId xmlns:r="http://schemas.openxmlformats.org/officeDocument/2006/relationships" id="256" r:id="R14a4ee93effd4c88"/>
   </p:sldIdLst>
   <p:sldSz cx="12192000" cy="6858000"/>
   <p:notesSz cx="6858000" cy="9144000"/>
@@ -506,7 +506,7 @@
   </p:cSld>
   <p:clrMap bg1="lt1" tx1="dk1" bg2="lt2" tx2="dk2" accent1="accent1" accent2="accent2" accent3="accent3" accent4="accent4" accent5="accent5" accent6="accent6" hlink="hlink" folHlink="folHlink"/>
   <p:sldLayoutIdLst>
-    <p:sldLayoutId xmlns:r="http://schemas.openxmlformats.org/officeDocument/2006/relationships" id="2147483649" r:id="R28152467911e4692"/>
+    <p:sldLayoutId xmlns:r="http://schemas.openxmlformats.org/officeDocument/2006/relationships" id="2147483649" r:id="R861e5d026fbb423d"/>
   </p:sldLayoutIdLst>
   <p:txStyles>
     <p:titleStyle>
@@ -1054,10 +1054,10 @@
       </p:grpSpPr>
       <p:sp>
         <p:nvSpPr>
-          <p:cNvPr id="40" name="cycle-panel-0">
+          <p:cNvPr id="36" name="cycle-panel-0">
             <a:extLst xmlns:a="http://schemas.openxmlformats.org/drawingml/2006/main">
               <a:ext uri="{FF2B5EF4-FFF2-40B4-BE49-F238E27FC236}">
-                <a16:creationId xmlns:a16="http://schemas.microsoft.com/office/drawing/2014/main" id="{98748293-D13F-4691-BE6F-33CED42E6014}"/>
+                <a16:creationId xmlns:a16="http://schemas.microsoft.com/office/drawing/2014/main" id="{B401D777-C52B-46B8-BE1B-E46F2442AC3D}"/>
               </a:ext>
             </a:extLst>
           </p:cNvPr>
@@ -1085,10 +1085,10 @@
       </p:sp>
       <p:sp>
         <p:nvSpPr>
-          <p:cNvPr id="2" name="cycle-0-copy-line-0">
+          <p:cNvPr id="2" name="cycle-0-support">
             <a:extLst xmlns:a="http://schemas.openxmlformats.org/drawingml/2006/main">
               <a:ext uri="{FF2B5EF4-FFF2-40B4-BE49-F238E27FC236}">
-                <a16:creationId xmlns:a16="http://schemas.microsoft.com/office/drawing/2014/main" id="{E39A79AF-732A-4D5D-81D3-2C461269BB2E}"/>
+                <a16:creationId xmlns:a16="http://schemas.microsoft.com/office/drawing/2014/main" id="{B9DE11E2-46DC-4764-B17E-902644F593FD}"/>
               </a:ext>
             </a:extLst>
           </p:cNvPr>
@@ -1099,8 +1099,8 @@
         </p:nvSpPr>
         <p:spPr>
           <a:xfrm xmlns:a="http://schemas.openxmlformats.org/drawingml/2006/main" rot="0">
-            <a:off x="790575" y="2155631"/>
-            <a:ext cx="2733675" cy="179489"/>
+            <a:off x="790575" y="1965427"/>
+            <a:ext cx="2733675" cy="269824"/>
           </a:xfrm>
           <a:prstGeom xmlns:a="http://schemas.openxmlformats.org/drawingml/2006/main" prst="rect">
             <a:avLst/>
@@ -1112,13 +1112,17 @@
           </a:ln>
         </p:spPr>
         <p:txBody>
-          <a:bodyPr xmlns:a="http://schemas.openxmlformats.org/drawingml/2006/main" lIns="0" tIns="0" rIns="0" bIns="0" anchor="ctr">
-            <a:normAutofit fontScale="100000"/>
+          <a:bodyPr xmlns:a="http://schemas.openxmlformats.org/drawingml/2006/main" wrap="none" lIns="0" tIns="0" rIns="0" bIns="0" anchor="ctr">
+            <a:noAutofit/>
           </a:bodyPr>
           <a:lstStyle xmlns:a="http://schemas.openxmlformats.org/drawingml/2006/main"/>
           <a:p xmlns:a="http://schemas.openxmlformats.org/drawingml/2006/main">
             <a:pPr algn="l">
-              <a:defRPr sz="975" b="0" i="0">
+              <a:lnSpc>
+                <a:spcPct val="125000"/>
+              </a:lnSpc>
+              <a:buNone/>
+              <a:defRPr sz="1700" b="0" i="0">
                 <a:solidFill>
                   <a:srgbClr val="666666"/>
                 </a:solidFill>
@@ -1128,7 +1132,7 @@
               </a:defRPr>
             </a:pPr>
             <a:r>
-              <a:rPr sz="975" b="0" i="0">
+              <a:rPr sz="1700" b="0" i="0">
                 <a:solidFill>
                   <a:srgbClr val="666666"/>
                 </a:solidFill>
@@ -1143,10 +1147,10 @@
       </p:sp>
       <p:sp>
         <p:nvSpPr>
-          <p:cNvPr id="3" name="cycle-0-copy-line-1">
+          <p:cNvPr id="3" name="cycle-0-point-0">
             <a:extLst xmlns:a="http://schemas.openxmlformats.org/drawingml/2006/main">
               <a:ext uri="{FF2B5EF4-FFF2-40B4-BE49-F238E27FC236}">
-                <a16:creationId xmlns:a16="http://schemas.microsoft.com/office/drawing/2014/main" id="{33F7E9E9-BCFA-440C-93BC-75720F146C6F}"/>
+                <a16:creationId xmlns:a16="http://schemas.microsoft.com/office/drawing/2014/main" id="{B40D926B-425B-4354-9ABD-62593594B74A}"/>
               </a:ext>
             </a:extLst>
           </p:cNvPr>
@@ -1157,8 +1161,8 @@
         </p:nvSpPr>
         <p:spPr>
           <a:xfrm xmlns:a="http://schemas.openxmlformats.org/drawingml/2006/main" rot="0">
-            <a:off x="790575" y="2411311"/>
-            <a:ext cx="2733675" cy="179489"/>
+            <a:off x="790575" y="2330501"/>
+            <a:ext cx="2733675" cy="269824"/>
           </a:xfrm>
           <a:prstGeom xmlns:a="http://schemas.openxmlformats.org/drawingml/2006/main" prst="rect">
             <a:avLst/>
@@ -1170,13 +1174,17 @@
           </a:ln>
         </p:spPr>
         <p:txBody>
-          <a:bodyPr xmlns:a="http://schemas.openxmlformats.org/drawingml/2006/main" lIns="0" tIns="0" rIns="0" bIns="0" anchor="ctr">
-            <a:normAutofit fontScale="100000"/>
+          <a:bodyPr xmlns:a="http://schemas.openxmlformats.org/drawingml/2006/main" wrap="none" lIns="0" tIns="0" rIns="0" bIns="0" anchor="ctr">
+            <a:noAutofit/>
           </a:bodyPr>
           <a:lstStyle xmlns:a="http://schemas.openxmlformats.org/drawingml/2006/main"/>
           <a:p xmlns:a="http://schemas.openxmlformats.org/drawingml/2006/main">
             <a:pPr algn="l">
-              <a:defRPr sz="975" b="0" i="0">
+              <a:lnSpc>
+                <a:spcPct val="125000"/>
+              </a:lnSpc>
+              <a:buNone/>
+              <a:defRPr sz="1700" b="0" i="0">
                 <a:solidFill>
                   <a:srgbClr val="666666"/>
                 </a:solidFill>
@@ -1186,7 +1194,7 @@
               </a:defRPr>
             </a:pPr>
             <a:r>
-              <a:rPr sz="975" b="0" i="0">
+              <a:rPr sz="1700" b="0" i="0">
                 <a:solidFill>
                   <a:srgbClr val="666666"/>
                 </a:solidFill>
@@ -1194,17 +1202,17 @@
                 <a:ea typeface="Microsoft YaHei"/>
                 <a:cs typeface="Microsoft YaHei"/>
               </a:rPr>
-              <a:t>分析现状与约束</a:t>
+              <a:t>• 分析现状约束</a:t>
             </a:r>
           </a:p>
         </p:txBody>
       </p:sp>
       <p:sp>
         <p:nvSpPr>
-          <p:cNvPr id="4" name="cycle-0-copy-line-2">
+          <p:cNvPr id="4" name="cycle-0-point-1">
             <a:extLst xmlns:a="http://schemas.openxmlformats.org/drawingml/2006/main">
               <a:ext uri="{FF2B5EF4-FFF2-40B4-BE49-F238E27FC236}">
-                <a16:creationId xmlns:a16="http://schemas.microsoft.com/office/drawing/2014/main" id="{4161C414-FE62-446B-99E6-C09C213C359B}"/>
+                <a16:creationId xmlns:a16="http://schemas.microsoft.com/office/drawing/2014/main" id="{BDBB3001-8B7C-4F3A-B87B-0F62DD863EAC}"/>
               </a:ext>
             </a:extLst>
           </p:cNvPr>
@@ -1215,8 +1223,8 @@
         </p:nvSpPr>
         <p:spPr>
           <a:xfrm xmlns:a="http://schemas.openxmlformats.org/drawingml/2006/main" rot="0">
-            <a:off x="790575" y="2667000"/>
-            <a:ext cx="2733675" cy="179489"/>
+            <a:off x="790575" y="2676525"/>
+            <a:ext cx="2733675" cy="269824"/>
           </a:xfrm>
           <a:prstGeom xmlns:a="http://schemas.openxmlformats.org/drawingml/2006/main" prst="rect">
             <a:avLst/>
@@ -1228,13 +1236,17 @@
           </a:ln>
         </p:spPr>
         <p:txBody>
-          <a:bodyPr xmlns:a="http://schemas.openxmlformats.org/drawingml/2006/main" lIns="0" tIns="0" rIns="0" bIns="0" anchor="ctr">
-            <a:normAutofit fontScale="100000"/>
+          <a:bodyPr xmlns:a="http://schemas.openxmlformats.org/drawingml/2006/main" wrap="none" lIns="0" tIns="0" rIns="0" bIns="0" anchor="ctr">
+            <a:noAutofit/>
           </a:bodyPr>
           <a:lstStyle xmlns:a="http://schemas.openxmlformats.org/drawingml/2006/main"/>
           <a:p xmlns:a="http://schemas.openxmlformats.org/drawingml/2006/main">
             <a:pPr algn="l">
-              <a:defRPr sz="975" b="0" i="0">
+              <a:lnSpc>
+                <a:spcPct val="125000"/>
+              </a:lnSpc>
+              <a:buNone/>
+              <a:defRPr sz="1700" b="0" i="0">
                 <a:solidFill>
                   <a:srgbClr val="666666"/>
                 </a:solidFill>
@@ -1244,7 +1256,7 @@
               </a:defRPr>
             </a:pPr>
             <a:r>
-              <a:rPr sz="975" b="0" i="0">
+              <a:rPr sz="1700" b="0" i="0">
                 <a:solidFill>
                   <a:srgbClr val="666666"/>
                 </a:solidFill>
@@ -1252,17 +1264,17 @@
                 <a:ea typeface="Microsoft YaHei"/>
                 <a:cs typeface="Microsoft YaHei"/>
               </a:rPr>
-              <a:t>确定优先问题</a:t>
+              <a:t>• 确定优先问题</a:t>
             </a:r>
           </a:p>
         </p:txBody>
       </p:sp>
       <p:sp>
         <p:nvSpPr>
-          <p:cNvPr id="5" name="cycle-0-copy-line-3">
+          <p:cNvPr id="5" name="cycle-0-point-2">
             <a:extLst xmlns:a="http://schemas.openxmlformats.org/drawingml/2006/main">
               <a:ext uri="{FF2B5EF4-FFF2-40B4-BE49-F238E27FC236}">
-                <a16:creationId xmlns:a16="http://schemas.microsoft.com/office/drawing/2014/main" id="{9CF5D5BD-50AA-46A2-AAA7-36D74FF6CA96}"/>
+                <a16:creationId xmlns:a16="http://schemas.microsoft.com/office/drawing/2014/main" id="{EFEB9948-F18F-4C92-914A-021BAC84F947}"/>
               </a:ext>
             </a:extLst>
           </p:cNvPr>
@@ -1273,8 +1285,8 @@
         </p:nvSpPr>
         <p:spPr>
           <a:xfrm xmlns:a="http://schemas.openxmlformats.org/drawingml/2006/main" rot="0">
-            <a:off x="790575" y="2922689"/>
-            <a:ext cx="2733675" cy="179489"/>
+            <a:off x="790575" y="3022549"/>
+            <a:ext cx="2733675" cy="269824"/>
           </a:xfrm>
           <a:prstGeom xmlns:a="http://schemas.openxmlformats.org/drawingml/2006/main" prst="rect">
             <a:avLst/>
@@ -1286,13 +1298,17 @@
           </a:ln>
         </p:spPr>
         <p:txBody>
-          <a:bodyPr xmlns:a="http://schemas.openxmlformats.org/drawingml/2006/main" lIns="0" tIns="0" rIns="0" bIns="0" anchor="ctr">
-            <a:normAutofit fontScale="100000"/>
+          <a:bodyPr xmlns:a="http://schemas.openxmlformats.org/drawingml/2006/main" wrap="none" lIns="0" tIns="0" rIns="0" bIns="0" anchor="ctr">
+            <a:noAutofit/>
           </a:bodyPr>
           <a:lstStyle xmlns:a="http://schemas.openxmlformats.org/drawingml/2006/main"/>
           <a:p xmlns:a="http://schemas.openxmlformats.org/drawingml/2006/main">
             <a:pPr algn="l">
-              <a:defRPr sz="975" b="0" i="0">
+              <a:lnSpc>
+                <a:spcPct val="125000"/>
+              </a:lnSpc>
+              <a:buNone/>
+              <a:defRPr sz="1700" b="0" i="0">
                 <a:solidFill>
                   <a:srgbClr val="666666"/>
                 </a:solidFill>
@@ -1302,7 +1318,7 @@
               </a:defRPr>
             </a:pPr>
             <a:r>
-              <a:rPr sz="975" b="0" i="0">
+              <a:rPr sz="1700" b="0" i="0">
                 <a:solidFill>
                   <a:srgbClr val="666666"/>
                 </a:solidFill>
@@ -1310,7 +1326,7 @@
                 <a:ea typeface="Microsoft YaHei"/>
                 <a:cs typeface="Microsoft YaHei"/>
               </a:rPr>
-              <a:t>形成行动计划</a:t>
+              <a:t>• 形成行动计划</a:t>
             </a:r>
           </a:p>
         </p:txBody>
@@ -1320,7 +1336,7 @@
           <p:cNvPr id="6" name="cycle-panel-3">
             <a:extLst xmlns:a="http://schemas.openxmlformats.org/drawingml/2006/main">
               <a:ext uri="{FF2B5EF4-FFF2-40B4-BE49-F238E27FC236}">
-                <a16:creationId xmlns:a16="http://schemas.microsoft.com/office/drawing/2014/main" id="{06CED80A-9F7A-48C8-ABC9-FDF146B1F25D}"/>
+                <a16:creationId xmlns:a16="http://schemas.microsoft.com/office/drawing/2014/main" id="{F99FB26D-69B7-40F8-A74E-AB177B226329}"/>
               </a:ext>
             </a:extLst>
           </p:cNvPr>
@@ -1348,10 +1364,10 @@
       </p:sp>
       <p:sp>
         <p:nvSpPr>
-          <p:cNvPr id="7" name="cycle-3-copy-line-0">
+          <p:cNvPr id="7" name="cycle-3-support">
             <a:extLst xmlns:a="http://schemas.openxmlformats.org/drawingml/2006/main">
               <a:ext uri="{FF2B5EF4-FFF2-40B4-BE49-F238E27FC236}">
-                <a16:creationId xmlns:a16="http://schemas.microsoft.com/office/drawing/2014/main" id="{CEB38BAE-D847-42E2-A53B-71BD2461F578}"/>
+                <a16:creationId xmlns:a16="http://schemas.microsoft.com/office/drawing/2014/main" id="{FBF89F43-B1C3-44C6-8E4E-A6AEE2191B1A}"/>
               </a:ext>
             </a:extLst>
           </p:cNvPr>
@@ -1362,8 +1378,8 @@
         </p:nvSpPr>
         <p:spPr>
           <a:xfrm xmlns:a="http://schemas.openxmlformats.org/drawingml/2006/main" rot="0">
-            <a:off x="790575" y="4874266"/>
-            <a:ext cx="2733675" cy="179489"/>
+            <a:off x="790575" y="4729163"/>
+            <a:ext cx="2733675" cy="269824"/>
           </a:xfrm>
           <a:prstGeom xmlns:a="http://schemas.openxmlformats.org/drawingml/2006/main" prst="rect">
             <a:avLst/>
@@ -1375,13 +1391,17 @@
           </a:ln>
         </p:spPr>
         <p:txBody>
-          <a:bodyPr xmlns:a="http://schemas.openxmlformats.org/drawingml/2006/main" lIns="0" tIns="0" rIns="0" bIns="0" anchor="ctr">
-            <a:normAutofit fontScale="100000"/>
+          <a:bodyPr xmlns:a="http://schemas.openxmlformats.org/drawingml/2006/main" wrap="none" lIns="0" tIns="0" rIns="0" bIns="0" anchor="ctr">
+            <a:noAutofit/>
           </a:bodyPr>
           <a:lstStyle xmlns:a="http://schemas.openxmlformats.org/drawingml/2006/main"/>
           <a:p xmlns:a="http://schemas.openxmlformats.org/drawingml/2006/main">
             <a:pPr algn="l">
-              <a:defRPr sz="975" b="0" i="0">
+              <a:lnSpc>
+                <a:spcPct val="125000"/>
+              </a:lnSpc>
+              <a:buNone/>
+              <a:defRPr sz="1700" b="0" i="0">
                 <a:solidFill>
                   <a:srgbClr val="666666"/>
                 </a:solidFill>
@@ -1391,7 +1411,7 @@
               </a:defRPr>
             </a:pPr>
             <a:r>
-              <a:rPr sz="975" b="0" i="0">
+              <a:rPr sz="1700" b="0" i="0">
                 <a:solidFill>
                   <a:srgbClr val="666666"/>
                 </a:solidFill>
@@ -1406,10 +1426,10 @@
       </p:sp>
       <p:sp>
         <p:nvSpPr>
-          <p:cNvPr id="8" name="cycle-3-copy-line-1">
+          <p:cNvPr id="8" name="cycle-3-point-0">
             <a:extLst xmlns:a="http://schemas.openxmlformats.org/drawingml/2006/main">
               <a:ext uri="{FF2B5EF4-FFF2-40B4-BE49-F238E27FC236}">
-                <a16:creationId xmlns:a16="http://schemas.microsoft.com/office/drawing/2014/main" id="{ADC6DB82-CAC3-459A-B455-FC2A56322C99}"/>
+                <a16:creationId xmlns:a16="http://schemas.microsoft.com/office/drawing/2014/main" id="{3BBC352E-C1B4-45CB-9E16-FD1F0687ACA7}"/>
               </a:ext>
             </a:extLst>
           </p:cNvPr>
@@ -1420,8 +1440,8 @@
         </p:nvSpPr>
         <p:spPr>
           <a:xfrm xmlns:a="http://schemas.openxmlformats.org/drawingml/2006/main" rot="0">
-            <a:off x="790575" y="5129955"/>
-            <a:ext cx="2733675" cy="179489"/>
+            <a:off x="790575" y="5094237"/>
+            <a:ext cx="2733675" cy="269824"/>
           </a:xfrm>
           <a:prstGeom xmlns:a="http://schemas.openxmlformats.org/drawingml/2006/main" prst="rect">
             <a:avLst/>
@@ -1433,13 +1453,17 @@
           </a:ln>
         </p:spPr>
         <p:txBody>
-          <a:bodyPr xmlns:a="http://schemas.openxmlformats.org/drawingml/2006/main" lIns="0" tIns="0" rIns="0" bIns="0" anchor="ctr">
-            <a:normAutofit fontScale="100000"/>
+          <a:bodyPr xmlns:a="http://schemas.openxmlformats.org/drawingml/2006/main" wrap="none" lIns="0" tIns="0" rIns="0" bIns="0" anchor="ctr">
+            <a:noAutofit/>
           </a:bodyPr>
           <a:lstStyle xmlns:a="http://schemas.openxmlformats.org/drawingml/2006/main"/>
           <a:p xmlns:a="http://schemas.openxmlformats.org/drawingml/2006/main">
             <a:pPr algn="l">
-              <a:defRPr sz="975" b="0" i="0">
+              <a:lnSpc>
+                <a:spcPct val="125000"/>
+              </a:lnSpc>
+              <a:buNone/>
+              <a:defRPr sz="1700" b="0" i="0">
                 <a:solidFill>
                   <a:srgbClr val="666666"/>
                 </a:solidFill>
@@ -1449,7 +1473,7 @@
               </a:defRPr>
             </a:pPr>
             <a:r>
-              <a:rPr sz="975" b="0" i="0">
+              <a:rPr sz="1700" b="0" i="0">
                 <a:solidFill>
                   <a:srgbClr val="666666"/>
                 </a:solidFill>
@@ -1457,17 +1481,17 @@
                 <a:ea typeface="Microsoft YaHei"/>
                 <a:cs typeface="Microsoft YaHei"/>
               </a:rPr>
-              <a:t>修正未达预期环节</a:t>
+              <a:t>• 修正未达预期</a:t>
             </a:r>
           </a:p>
         </p:txBody>
       </p:sp>
       <p:sp>
         <p:nvSpPr>
-          <p:cNvPr id="9" name="cycle-3-copy-line-2">
+          <p:cNvPr id="9" name="cycle-3-point-1">
             <a:extLst xmlns:a="http://schemas.openxmlformats.org/drawingml/2006/main">
               <a:ext uri="{FF2B5EF4-FFF2-40B4-BE49-F238E27FC236}">
-                <a16:creationId xmlns:a16="http://schemas.microsoft.com/office/drawing/2014/main" id="{9BCDCC7E-F2A4-4C14-ABF9-A9A2AD1EABE2}"/>
+                <a16:creationId xmlns:a16="http://schemas.microsoft.com/office/drawing/2014/main" id="{9683DE7A-10EF-40F7-BD92-338D1B3431F4}"/>
               </a:ext>
             </a:extLst>
           </p:cNvPr>
@@ -1478,8 +1502,8 @@
         </p:nvSpPr>
         <p:spPr>
           <a:xfrm xmlns:a="http://schemas.openxmlformats.org/drawingml/2006/main" rot="0">
-            <a:off x="790575" y="5385645"/>
-            <a:ext cx="2733675" cy="179489"/>
+            <a:off x="790575" y="5440261"/>
+            <a:ext cx="2733675" cy="269824"/>
           </a:xfrm>
           <a:prstGeom xmlns:a="http://schemas.openxmlformats.org/drawingml/2006/main" prst="rect">
             <a:avLst/>
@@ -1491,13 +1515,17 @@
           </a:ln>
         </p:spPr>
         <p:txBody>
-          <a:bodyPr xmlns:a="http://schemas.openxmlformats.org/drawingml/2006/main" lIns="0" tIns="0" rIns="0" bIns="0" anchor="ctr">
-            <a:normAutofit fontScale="100000"/>
+          <a:bodyPr xmlns:a="http://schemas.openxmlformats.org/drawingml/2006/main" wrap="none" lIns="0" tIns="0" rIns="0" bIns="0" anchor="ctr">
+            <a:noAutofit/>
           </a:bodyPr>
           <a:lstStyle xmlns:a="http://schemas.openxmlformats.org/drawingml/2006/main"/>
           <a:p xmlns:a="http://schemas.openxmlformats.org/drawingml/2006/main">
             <a:pPr algn="l">
-              <a:defRPr sz="975" b="0" i="0">
+              <a:lnSpc>
+                <a:spcPct val="125000"/>
+              </a:lnSpc>
+              <a:buNone/>
+              <a:defRPr sz="1700" b="0" i="0">
                 <a:solidFill>
                   <a:srgbClr val="666666"/>
                 </a:solidFill>
@@ -1507,7 +1535,7 @@
               </a:defRPr>
             </a:pPr>
             <a:r>
-              <a:rPr sz="975" b="0" i="0">
+              <a:rPr sz="1700" b="0" i="0">
                 <a:solidFill>
                   <a:srgbClr val="666666"/>
                 </a:solidFill>
@@ -1515,7 +1543,7 @@
                 <a:ea typeface="Microsoft YaHei"/>
                 <a:cs typeface="Microsoft YaHei"/>
               </a:rPr>
-              <a:t>进入下一轮循环</a:t>
+              <a:t>• 进入下一循环</a:t>
             </a:r>
           </a:p>
         </p:txBody>
@@ -1525,7 +1553,7 @@
           <p:cNvPr id="10" name="cycle-panel-1">
             <a:extLst xmlns:a="http://schemas.openxmlformats.org/drawingml/2006/main">
               <a:ext uri="{FF2B5EF4-FFF2-40B4-BE49-F238E27FC236}">
-                <a16:creationId xmlns:a16="http://schemas.microsoft.com/office/drawing/2014/main" id="{963016BC-03D2-4AAA-A68E-BEEFCFA1293E}"/>
+                <a16:creationId xmlns:a16="http://schemas.microsoft.com/office/drawing/2014/main" id="{CE2CA4C9-B702-4C8B-891B-1E94AE5C5EF4}"/>
               </a:ext>
             </a:extLst>
           </p:cNvPr>
@@ -1553,10 +1581,10 @@
       </p:sp>
       <p:sp>
         <p:nvSpPr>
-          <p:cNvPr id="11" name="cycle-1-copy-line-0">
+          <p:cNvPr id="11" name="cycle-1-support">
             <a:extLst xmlns:a="http://schemas.openxmlformats.org/drawingml/2006/main">
               <a:ext uri="{FF2B5EF4-FFF2-40B4-BE49-F238E27FC236}">
-                <a16:creationId xmlns:a16="http://schemas.microsoft.com/office/drawing/2014/main" id="{D3D6D4F1-6E27-4F94-89C1-3EF519D1A38B}"/>
+                <a16:creationId xmlns:a16="http://schemas.microsoft.com/office/drawing/2014/main" id="{CA0D7D39-6CF2-4397-A71D-4163A524DE5B}"/>
               </a:ext>
             </a:extLst>
           </p:cNvPr>
@@ -1567,8 +1595,8 @@
         </p:nvSpPr>
         <p:spPr>
           <a:xfrm xmlns:a="http://schemas.openxmlformats.org/drawingml/2006/main" rot="0">
-            <a:off x="8667750" y="2411311"/>
-            <a:ext cx="2733675" cy="179489"/>
+            <a:off x="8667750" y="2311451"/>
+            <a:ext cx="2733675" cy="269824"/>
           </a:xfrm>
           <a:prstGeom xmlns:a="http://schemas.openxmlformats.org/drawingml/2006/main" prst="rect">
             <a:avLst/>
@@ -1580,13 +1608,17 @@
           </a:ln>
         </p:spPr>
         <p:txBody>
-          <a:bodyPr xmlns:a="http://schemas.openxmlformats.org/drawingml/2006/main" lIns="0" tIns="0" rIns="0" bIns="0" anchor="ctr">
-            <a:normAutofit fontScale="100000"/>
+          <a:bodyPr xmlns:a="http://schemas.openxmlformats.org/drawingml/2006/main" wrap="none" lIns="0" tIns="0" rIns="0" bIns="0" anchor="ctr">
+            <a:noAutofit/>
           </a:bodyPr>
           <a:lstStyle xmlns:a="http://schemas.openxmlformats.org/drawingml/2006/main"/>
           <a:p xmlns:a="http://schemas.openxmlformats.org/drawingml/2006/main">
             <a:pPr algn="r">
-              <a:defRPr sz="975" b="0" i="0">
+              <a:lnSpc>
+                <a:spcPct val="125000"/>
+              </a:lnSpc>
+              <a:buNone/>
+              <a:defRPr sz="1700" b="0" i="0">
                 <a:solidFill>
                   <a:srgbClr val="666666"/>
                 </a:solidFill>
@@ -1596,7 +1628,7 @@
               </a:defRPr>
             </a:pPr>
             <a:r>
-              <a:rPr sz="975" b="0" i="0">
+              <a:rPr sz="1700" b="0" i="0">
                 <a:solidFill>
                   <a:srgbClr val="666666"/>
                 </a:solidFill>
@@ -1604,17 +1636,17 @@
                 <a:ea typeface="Microsoft YaHei"/>
                 <a:cs typeface="Microsoft YaHei"/>
               </a:rPr>
-              <a:t>按计划推进重点行动</a:t>
+              <a:t>推进重点行动</a:t>
             </a:r>
           </a:p>
         </p:txBody>
       </p:sp>
       <p:sp>
         <p:nvSpPr>
-          <p:cNvPr id="12" name="cycle-1-copy-line-1">
+          <p:cNvPr id="12" name="cycle-1-point-0">
             <a:extLst xmlns:a="http://schemas.openxmlformats.org/drawingml/2006/main">
               <a:ext uri="{FF2B5EF4-FFF2-40B4-BE49-F238E27FC236}">
-                <a16:creationId xmlns:a16="http://schemas.microsoft.com/office/drawing/2014/main" id="{3107490A-79EC-4128-813E-2AA0A0F8A442}"/>
+                <a16:creationId xmlns:a16="http://schemas.microsoft.com/office/drawing/2014/main" id="{65227CF7-4C19-4CBB-8DA8-ECC51C423DA9}"/>
               </a:ext>
             </a:extLst>
           </p:cNvPr>
@@ -1625,8 +1657,8 @@
         </p:nvSpPr>
         <p:spPr>
           <a:xfrm xmlns:a="http://schemas.openxmlformats.org/drawingml/2006/main" rot="0">
-            <a:off x="8667750" y="2667000"/>
-            <a:ext cx="2733675" cy="179489"/>
+            <a:off x="8667750" y="2676525"/>
+            <a:ext cx="2733675" cy="269824"/>
           </a:xfrm>
           <a:prstGeom xmlns:a="http://schemas.openxmlformats.org/drawingml/2006/main" prst="rect">
             <a:avLst/>
@@ -1638,13 +1670,17 @@
           </a:ln>
         </p:spPr>
         <p:txBody>
-          <a:bodyPr xmlns:a="http://schemas.openxmlformats.org/drawingml/2006/main" lIns="0" tIns="0" rIns="0" bIns="0" anchor="ctr">
-            <a:normAutofit fontScale="100000"/>
+          <a:bodyPr xmlns:a="http://schemas.openxmlformats.org/drawingml/2006/main" wrap="none" lIns="0" tIns="0" rIns="0" bIns="0" anchor="ctr">
+            <a:noAutofit/>
           </a:bodyPr>
           <a:lstStyle xmlns:a="http://schemas.openxmlformats.org/drawingml/2006/main"/>
           <a:p xmlns:a="http://schemas.openxmlformats.org/drawingml/2006/main">
             <a:pPr algn="r">
-              <a:defRPr sz="975" b="0" i="0">
+              <a:lnSpc>
+                <a:spcPct val="125000"/>
+              </a:lnSpc>
+              <a:buNone/>
+              <a:defRPr sz="1700" b="0" i="0">
                 <a:solidFill>
                   <a:srgbClr val="666666"/>
                 </a:solidFill>
@@ -1654,7 +1690,7 @@
               </a:defRPr>
             </a:pPr>
             <a:r>
-              <a:rPr sz="975" b="0" i="0">
+              <a:rPr sz="1700" b="0" i="0">
                 <a:solidFill>
                   <a:srgbClr val="666666"/>
                 </a:solidFill>
@@ -1662,7 +1698,7 @@
                 <a:ea typeface="Microsoft YaHei"/>
                 <a:cs typeface="Microsoft YaHei"/>
               </a:rPr>
-              <a:t>同步责任与分工</a:t>
+              <a:t>• 同步责任分工</a:t>
             </a:r>
           </a:p>
         </p:txBody>
@@ -1672,7 +1708,7 @@
           <p:cNvPr id="13" name="cycle-panel-2">
             <a:extLst xmlns:a="http://schemas.openxmlformats.org/drawingml/2006/main">
               <a:ext uri="{FF2B5EF4-FFF2-40B4-BE49-F238E27FC236}">
-                <a16:creationId xmlns:a16="http://schemas.microsoft.com/office/drawing/2014/main" id="{C2066633-3A3C-405E-90E6-1B1C4DF391BA}"/>
+                <a16:creationId xmlns:a16="http://schemas.microsoft.com/office/drawing/2014/main" id="{26612E03-0FD3-4DDF-81D9-D090BF775B26}"/>
               </a:ext>
             </a:extLst>
           </p:cNvPr>
@@ -1700,10 +1736,10 @@
       </p:sp>
       <p:sp>
         <p:nvSpPr>
-          <p:cNvPr id="14" name="cycle-2-copy-line-0">
+          <p:cNvPr id="14" name="cycle-2-support">
             <a:extLst xmlns:a="http://schemas.openxmlformats.org/drawingml/2006/main">
               <a:ext uri="{FF2B5EF4-FFF2-40B4-BE49-F238E27FC236}">
-                <a16:creationId xmlns:a16="http://schemas.microsoft.com/office/drawing/2014/main" id="{0BA40724-5961-416D-80D0-2A0E00721F89}"/>
+                <a16:creationId xmlns:a16="http://schemas.microsoft.com/office/drawing/2014/main" id="{971A3F73-9B23-4B62-9393-736A55217AAB}"/>
               </a:ext>
             </a:extLst>
           </p:cNvPr>
@@ -1714,8 +1750,8 @@
         </p:nvSpPr>
         <p:spPr>
           <a:xfrm xmlns:a="http://schemas.openxmlformats.org/drawingml/2006/main" rot="0">
-            <a:off x="8667750" y="5129955"/>
-            <a:ext cx="2733675" cy="179489"/>
+            <a:off x="8667750" y="5084712"/>
+            <a:ext cx="2733675" cy="269824"/>
           </a:xfrm>
           <a:prstGeom xmlns:a="http://schemas.openxmlformats.org/drawingml/2006/main" prst="rect">
             <a:avLst/>
@@ -1727,13 +1763,17 @@
           </a:ln>
         </p:spPr>
         <p:txBody>
-          <a:bodyPr xmlns:a="http://schemas.openxmlformats.org/drawingml/2006/main" lIns="0" tIns="0" rIns="0" bIns="0" anchor="ctr">
-            <a:normAutofit fontScale="100000"/>
+          <a:bodyPr xmlns:a="http://schemas.openxmlformats.org/drawingml/2006/main" wrap="none" lIns="0" tIns="0" rIns="0" bIns="0" anchor="ctr">
+            <a:noAutofit/>
           </a:bodyPr>
           <a:lstStyle xmlns:a="http://schemas.openxmlformats.org/drawingml/2006/main"/>
           <a:p xmlns:a="http://schemas.openxmlformats.org/drawingml/2006/main">
             <a:pPr algn="r">
-              <a:defRPr sz="975" b="0" i="0">
+              <a:lnSpc>
+                <a:spcPct val="125000"/>
+              </a:lnSpc>
+              <a:buNone/>
+              <a:defRPr sz="1700" b="0" i="0">
                 <a:solidFill>
                   <a:srgbClr val="666666"/>
                 </a:solidFill>
@@ -1743,7 +1783,7 @@
               </a:defRPr>
             </a:pPr>
             <a:r>
-              <a:rPr sz="975" b="0" i="0">
+              <a:rPr sz="1700" b="0" i="0">
                 <a:solidFill>
                   <a:srgbClr val="666666"/>
                 </a:solidFill>
@@ -1751,7 +1791,7 @@
                 <a:ea typeface="Microsoft YaHei"/>
                 <a:cs typeface="Microsoft YaHei"/>
               </a:rPr>
-              <a:t>对照目标检查实际结果</a:t>
+              <a:t>对照目标检查结果</a:t>
             </a:r>
           </a:p>
         </p:txBody>
@@ -1761,7 +1801,7 @@
           <p:cNvPr id="15" name="cycle-mask">
             <a:extLst xmlns:a="http://schemas.openxmlformats.org/drawingml/2006/main">
               <a:ext uri="{FF2B5EF4-FFF2-40B4-BE49-F238E27FC236}">
-                <a16:creationId xmlns:a16="http://schemas.microsoft.com/office/drawing/2014/main" id="{1B44C9BE-B083-4F7A-84CE-586CF54E0BF7}"/>
+                <a16:creationId xmlns:a16="http://schemas.microsoft.com/office/drawing/2014/main" id="{D51309DE-CA46-4829-8AEC-5270893D0C3B}"/>
               </a:ext>
             </a:extLst>
           </p:cNvPr>
@@ -1792,7 +1832,7 @@
           <p:cNvPr id="16" name="cycle-breath">
             <a:extLst xmlns:a="http://schemas.openxmlformats.org/drawingml/2006/main">
               <a:ext uri="{FF2B5EF4-FFF2-40B4-BE49-F238E27FC236}">
-                <a16:creationId xmlns:a16="http://schemas.microsoft.com/office/drawing/2014/main" id="{47603AED-AD8E-41C6-85FF-B972C2680466}"/>
+                <a16:creationId xmlns:a16="http://schemas.microsoft.com/office/drawing/2014/main" id="{FE8D700F-E67D-4859-B8F3-742F5DCD0006}"/>
               </a:ext>
             </a:extLst>
           </p:cNvPr>
@@ -1823,7 +1863,7 @@
           <p:cNvPr id="17" name="cycle-band-0">
             <a:extLst xmlns:a="http://schemas.openxmlformats.org/drawingml/2006/main">
               <a:ext uri="{FF2B5EF4-FFF2-40B4-BE49-F238E27FC236}">
-                <a16:creationId xmlns:a16="http://schemas.microsoft.com/office/drawing/2014/main" id="{B83DADAB-841E-43ED-8506-6767190944D3}"/>
+                <a16:creationId xmlns:a16="http://schemas.microsoft.com/office/drawing/2014/main" id="{96FD9008-78BF-4B7A-8F6B-0D92C9702B95}"/>
               </a:ext>
             </a:extLst>
           </p:cNvPr>
@@ -2581,7 +2621,7 @@
           <p:cNvPr id="18" name="cycle-band-1">
             <a:extLst xmlns:a="http://schemas.openxmlformats.org/drawingml/2006/main">
               <a:ext uri="{FF2B5EF4-FFF2-40B4-BE49-F238E27FC236}">
-                <a16:creationId xmlns:a16="http://schemas.microsoft.com/office/drawing/2014/main" id="{1B945ECF-6E68-4CD8-9193-9471F7B616F5}"/>
+                <a16:creationId xmlns:a16="http://schemas.microsoft.com/office/drawing/2014/main" id="{2FEE5B4D-E548-43F1-97BE-104130830180}"/>
               </a:ext>
             </a:extLst>
           </p:cNvPr>
@@ -3339,7 +3379,7 @@
           <p:cNvPr id="19" name="cycle-band-2">
             <a:extLst xmlns:a="http://schemas.openxmlformats.org/drawingml/2006/main">
               <a:ext uri="{FF2B5EF4-FFF2-40B4-BE49-F238E27FC236}">
-                <a16:creationId xmlns:a16="http://schemas.microsoft.com/office/drawing/2014/main" id="{3275DD05-7427-4DA9-B5CB-91C028FAA06A}"/>
+                <a16:creationId xmlns:a16="http://schemas.microsoft.com/office/drawing/2014/main" id="{C275240C-3972-4784-96A9-F256EA710351}"/>
               </a:ext>
             </a:extLst>
           </p:cNvPr>
@@ -4097,7 +4137,7 @@
           <p:cNvPr id="20" name="cycle-band-3">
             <a:extLst xmlns:a="http://schemas.openxmlformats.org/drawingml/2006/main">
               <a:ext uri="{FF2B5EF4-FFF2-40B4-BE49-F238E27FC236}">
-                <a16:creationId xmlns:a16="http://schemas.microsoft.com/office/drawing/2014/main" id="{B6ADC8EA-6A76-400B-B3C7-3F6686CF00C2}"/>
+                <a16:creationId xmlns:a16="http://schemas.microsoft.com/office/drawing/2014/main" id="{0FE1B77E-E57A-4CEA-A610-80368F18CD41}"/>
               </a:ext>
             </a:extLst>
           </p:cNvPr>
@@ -4855,7 +4895,7 @@
           <p:cNvPr id="21" name="cycle-arrow-0">
             <a:extLst xmlns:a="http://schemas.openxmlformats.org/drawingml/2006/main">
               <a:ext uri="{FF2B5EF4-FFF2-40B4-BE49-F238E27FC236}">
-                <a16:creationId xmlns:a16="http://schemas.microsoft.com/office/drawing/2014/main" id="{0352BAD9-2BD1-4F44-B053-8176C7F930EE}"/>
+                <a16:creationId xmlns:a16="http://schemas.microsoft.com/office/drawing/2014/main" id="{998836CC-5662-4E09-B5B9-6C28A943FE36}"/>
               </a:ext>
             </a:extLst>
           </p:cNvPr>
@@ -5274,7 +5314,7 @@
           <p:cNvPr id="22" name="cycle-arrow-1">
             <a:extLst xmlns:a="http://schemas.openxmlformats.org/drawingml/2006/main">
               <a:ext uri="{FF2B5EF4-FFF2-40B4-BE49-F238E27FC236}">
-                <a16:creationId xmlns:a16="http://schemas.microsoft.com/office/drawing/2014/main" id="{BFAABD35-8F5E-483E-B2AF-7CFCA9770B7F}"/>
+                <a16:creationId xmlns:a16="http://schemas.microsoft.com/office/drawing/2014/main" id="{507C754F-B34D-4274-83A8-EF9ED9E8F1E7}"/>
               </a:ext>
             </a:extLst>
           </p:cNvPr>
@@ -5693,7 +5733,7 @@
           <p:cNvPr id="23" name="cycle-arrow-2">
             <a:extLst xmlns:a="http://schemas.openxmlformats.org/drawingml/2006/main">
               <a:ext uri="{FF2B5EF4-FFF2-40B4-BE49-F238E27FC236}">
-                <a16:creationId xmlns:a16="http://schemas.microsoft.com/office/drawing/2014/main" id="{DDDAAF9A-C9AA-47BB-9622-928FF139F452}"/>
+                <a16:creationId xmlns:a16="http://schemas.microsoft.com/office/drawing/2014/main" id="{F1A0671B-542B-4CF8-860C-56AAF3AAAFD5}"/>
               </a:ext>
             </a:extLst>
           </p:cNvPr>
@@ -6112,7 +6152,7 @@
           <p:cNvPr id="24" name="cycle-arrow-3">
             <a:extLst xmlns:a="http://schemas.openxmlformats.org/drawingml/2006/main">
               <a:ext uri="{FF2B5EF4-FFF2-40B4-BE49-F238E27FC236}">
-                <a16:creationId xmlns:a16="http://schemas.microsoft.com/office/drawing/2014/main" id="{FF62F4D2-98E4-402A-A4F9-CDC816B58CEB}"/>
+                <a16:creationId xmlns:a16="http://schemas.microsoft.com/office/drawing/2014/main" id="{5908DB77-D259-4A02-9821-413080C348DF}"/>
               </a:ext>
             </a:extLst>
           </p:cNvPr>
@@ -6531,7 +6571,7 @@
           <p:cNvPr id="25" name="cycle-number-0">
             <a:extLst xmlns:a="http://schemas.openxmlformats.org/drawingml/2006/main">
               <a:ext uri="{FF2B5EF4-FFF2-40B4-BE49-F238E27FC236}">
-                <a16:creationId xmlns:a16="http://schemas.microsoft.com/office/drawing/2014/main" id="{6B4A4E67-2728-44AB-BEF7-2E260F5386A1}"/>
+                <a16:creationId xmlns:a16="http://schemas.microsoft.com/office/drawing/2014/main" id="{05ADFEDE-F258-483D-94A8-352B51E60942}"/>
               </a:ext>
             </a:extLst>
           </p:cNvPr>
@@ -6542,8 +6582,8 @@
         </p:nvSpPr>
         <p:spPr>
           <a:xfrm xmlns:a="http://schemas.openxmlformats.org/drawingml/2006/main" rot="0">
-            <a:off x="5417744" y="2078717"/>
-            <a:ext cx="412404" cy="390525"/>
+            <a:off x="5398322" y="2042255"/>
+            <a:ext cx="451247" cy="447675"/>
           </a:xfrm>
           <a:prstGeom xmlns:a="http://schemas.openxmlformats.org/drawingml/2006/main" prst="rect">
             <a:avLst/>
@@ -6555,15 +6595,21 @@
           </a:ln>
         </p:spPr>
         <p:txBody>
-          <a:bodyPr xmlns:a="http://schemas.openxmlformats.org/drawingml/2006/main" lIns="0" tIns="0" rIns="0" bIns="0" anchor="ctr">
-            <a:normAutofit fontScale="100000"/>
+          <a:bodyPr xmlns:a="http://schemas.openxmlformats.org/drawingml/2006/main" wrap="none" lIns="0" tIns="0" rIns="0" bIns="0" anchor="ctr">
+            <a:noAutofit/>
           </a:bodyPr>
           <a:lstStyle xmlns:a="http://schemas.openxmlformats.org/drawingml/2006/main"/>
           <a:p xmlns:a="http://schemas.openxmlformats.org/drawingml/2006/main">
             <a:pPr algn="ctr">
-              <a:defRPr sz="2175" b="0" i="0">
+              <a:lnSpc>
+                <a:spcPct val="100000"/>
+              </a:lnSpc>
+              <a:buNone/>
+              <a:defRPr sz="2500" b="0" i="0">
                 <a:solidFill>
-                  <a:srgbClr val="AEC1E6"/>
+                  <a:srgbClr val="AEC1E6">
+                    <a:alpha val="48000"/>
+                  </a:srgbClr>
                 </a:solidFill>
                 <a:latin typeface="Microsoft YaHei"/>
                 <a:ea typeface="Microsoft YaHei"/>
@@ -6571,9 +6617,11 @@
               </a:defRPr>
             </a:pPr>
             <a:r>
-              <a:rPr sz="2175" b="0" i="0">
+              <a:rPr sz="2500" b="0" i="0">
                 <a:solidFill>
-                  <a:srgbClr val="AEC1E6"/>
+                  <a:srgbClr val="AEC1E6">
+                    <a:alpha val="48000"/>
+                  </a:srgbClr>
                 </a:solidFill>
                 <a:latin typeface="Microsoft YaHei"/>
                 <a:ea typeface="Microsoft YaHei"/>
@@ -6589,7 +6637,7 @@
           <p:cNvPr id="26" name="cycle-title-0">
             <a:extLst xmlns:a="http://schemas.openxmlformats.org/drawingml/2006/main">
               <a:ext uri="{FF2B5EF4-FFF2-40B4-BE49-F238E27FC236}">
-                <a16:creationId xmlns:a16="http://schemas.microsoft.com/office/drawing/2014/main" id="{4CC1DC3E-D070-4706-A2D2-0AF793E03FF7}"/>
+                <a16:creationId xmlns:a16="http://schemas.microsoft.com/office/drawing/2014/main" id="{95D50F59-16DC-4B8C-9251-3FCA9B8E6872}"/>
               </a:ext>
             </a:extLst>
           </p:cNvPr>
@@ -6600,8 +6648,8 @@
         </p:nvSpPr>
         <p:spPr>
           <a:xfrm xmlns:a="http://schemas.openxmlformats.org/drawingml/2006/main" rot="-2700000">
-            <a:off x="4552340" y="2504465"/>
-            <a:ext cx="533400" cy="285750"/>
+            <a:off x="4467092" y="2443029"/>
+            <a:ext cx="685800" cy="390525"/>
           </a:xfrm>
           <a:prstGeom xmlns:a="http://schemas.openxmlformats.org/drawingml/2006/main" prst="rect">
             <a:avLst/>
@@ -6613,13 +6661,17 @@
           </a:ln>
         </p:spPr>
         <p:txBody>
-          <a:bodyPr xmlns:a="http://schemas.openxmlformats.org/drawingml/2006/main" lIns="0" tIns="0" rIns="0" bIns="0" anchor="ctr">
-            <a:normAutofit fontScale="100000"/>
+          <a:bodyPr xmlns:a="http://schemas.openxmlformats.org/drawingml/2006/main" wrap="none" lIns="0" tIns="0" rIns="0" bIns="0" anchor="ctr">
+            <a:noAutofit/>
           </a:bodyPr>
           <a:lstStyle xmlns:a="http://schemas.openxmlformats.org/drawingml/2006/main"/>
           <a:p xmlns:a="http://schemas.openxmlformats.org/drawingml/2006/main">
             <a:pPr algn="ctr">
-              <a:defRPr sz="1500" b="0" i="0">
+              <a:lnSpc>
+                <a:spcPct val="100000"/>
+              </a:lnSpc>
+              <a:buNone/>
+              <a:defRPr sz="2100" b="0" i="0">
                 <a:solidFill>
                   <a:srgbClr val="FFD176"/>
                 </a:solidFill>
@@ -6629,7 +6681,7 @@
               </a:defRPr>
             </a:pPr>
             <a:r>
-              <a:rPr sz="1500" b="0" i="0">
+              <a:rPr sz="2100" b="0" i="0">
                 <a:solidFill>
                   <a:srgbClr val="FFD176"/>
                 </a:solidFill>
@@ -6644,10 +6696,10 @@
       </p:sp>
       <p:sp>
         <p:nvSpPr>
-          <p:cNvPr id="27" name="cycle-english-0">
+          <p:cNvPr id="27" name="cycle-number-1">
             <a:extLst xmlns:a="http://schemas.openxmlformats.org/drawingml/2006/main">
               <a:ext uri="{FF2B5EF4-FFF2-40B4-BE49-F238E27FC236}">
-                <a16:creationId xmlns:a16="http://schemas.microsoft.com/office/drawing/2014/main" id="{7C36B050-BA1A-474B-82D2-AB4FBB5FFB58}"/>
+                <a16:creationId xmlns:a16="http://schemas.microsoft.com/office/drawing/2014/main" id="{58C33BDF-BCD0-43F2-8B47-051E9D2BB7AC}"/>
               </a:ext>
             </a:extLst>
           </p:cNvPr>
@@ -6657,9 +6709,9 @@
           <p:nvPr/>
         </p:nvSpPr>
         <p:spPr>
-          <a:xfrm xmlns:a="http://schemas.openxmlformats.org/drawingml/2006/main" rot="-2700000">
-            <a:off x="5232883" y="3212316"/>
-            <a:ext cx="540544" cy="238277"/>
+          <a:xfrm xmlns:a="http://schemas.openxmlformats.org/drawingml/2006/main" rot="0">
+            <a:off x="7468086" y="3195066"/>
+            <a:ext cx="505568" cy="447675"/>
           </a:xfrm>
           <a:prstGeom xmlns:a="http://schemas.openxmlformats.org/drawingml/2006/main" prst="rect">
             <a:avLst/>
@@ -6671,15 +6723,21 @@
           </a:ln>
         </p:spPr>
         <p:txBody>
-          <a:bodyPr xmlns:a="http://schemas.openxmlformats.org/drawingml/2006/main" lIns="0" tIns="0" rIns="0" bIns="0" anchor="ctr">
-            <a:normAutofit fontScale="100000"/>
+          <a:bodyPr xmlns:a="http://schemas.openxmlformats.org/drawingml/2006/main" wrap="none" lIns="0" tIns="0" rIns="0" bIns="0" anchor="ctr">
+            <a:noAutofit/>
           </a:bodyPr>
           <a:lstStyle xmlns:a="http://schemas.openxmlformats.org/drawingml/2006/main"/>
           <a:p xmlns:a="http://schemas.openxmlformats.org/drawingml/2006/main">
             <a:pPr algn="ctr">
-              <a:defRPr sz="1200" b="0" i="0">
+              <a:lnSpc>
+                <a:spcPct val="100000"/>
+              </a:lnSpc>
+              <a:buNone/>
+              <a:defRPr sz="2500" b="0" i="0">
                 <a:solidFill>
-                  <a:srgbClr val="777777"/>
+                  <a:srgbClr val="AEC1E6">
+                    <a:alpha val="48000"/>
+                  </a:srgbClr>
                 </a:solidFill>
                 <a:latin typeface="Microsoft YaHei"/>
                 <a:ea typeface="Microsoft YaHei"/>
@@ -6687,67 +6745,11 @@
               </a:defRPr>
             </a:pPr>
             <a:r>
-              <a:rPr sz="1200" b="0" i="0">
+              <a:rPr sz="2500" b="0" i="0">
                 <a:solidFill>
-                  <a:srgbClr val="777777"/>
-                </a:solidFill>
-                <a:latin typeface="Microsoft YaHei"/>
-                <a:ea typeface="Microsoft YaHei"/>
-                <a:cs typeface="Microsoft YaHei"/>
-              </a:rPr>
-              <a:t>Plan</a:t>
-            </a:r>
-          </a:p>
-        </p:txBody>
-      </p:sp>
-      <p:sp>
-        <p:nvSpPr>
-          <p:cNvPr id="28" name="cycle-number-1">
-            <a:extLst xmlns:a="http://schemas.openxmlformats.org/drawingml/2006/main">
-              <a:ext uri="{FF2B5EF4-FFF2-40B4-BE49-F238E27FC236}">
-                <a16:creationId xmlns:a16="http://schemas.microsoft.com/office/drawing/2014/main" id="{8F172F18-77DC-442A-A98A-4789FAF5A60D}"/>
-              </a:ext>
-            </a:extLst>
-          </p:cNvPr>
-          <p:cNvSpPr>
-            <a:spLocks xmlns:a="http://schemas.openxmlformats.org/drawingml/2006/main" noGrp="1"/>
-          </p:cNvSpPr>
-          <p:nvPr/>
-        </p:nvSpPr>
-        <p:spPr>
-          <a:xfrm xmlns:a="http://schemas.openxmlformats.org/drawingml/2006/main" rot="0">
-            <a:off x="7491003" y="3231528"/>
-            <a:ext cx="459734" cy="390525"/>
-          </a:xfrm>
-          <a:prstGeom xmlns:a="http://schemas.openxmlformats.org/drawingml/2006/main" prst="rect">
-            <a:avLst/>
-          </a:prstGeom>
-          <a:noFill xmlns:a="http://schemas.openxmlformats.org/drawingml/2006/main"/>
-          <a:ln xmlns:a="http://schemas.openxmlformats.org/drawingml/2006/main" w="0">
-            <a:noFill/>
-            <a:prstDash val="solid"/>
-          </a:ln>
-        </p:spPr>
-        <p:txBody>
-          <a:bodyPr xmlns:a="http://schemas.openxmlformats.org/drawingml/2006/main" lIns="0" tIns="0" rIns="0" bIns="0" anchor="ctr">
-            <a:normAutofit fontScale="100000"/>
-          </a:bodyPr>
-          <a:lstStyle xmlns:a="http://schemas.openxmlformats.org/drawingml/2006/main"/>
-          <a:p xmlns:a="http://schemas.openxmlformats.org/drawingml/2006/main">
-            <a:pPr algn="ctr">
-              <a:defRPr sz="2175" b="0" i="0">
-                <a:solidFill>
-                  <a:srgbClr val="AEC1E6"/>
-                </a:solidFill>
-                <a:latin typeface="Microsoft YaHei"/>
-                <a:ea typeface="Microsoft YaHei"/>
-                <a:cs typeface="Microsoft YaHei"/>
-              </a:defRPr>
-            </a:pPr>
-            <a:r>
-              <a:rPr sz="2175" b="0" i="0">
-                <a:solidFill>
-                  <a:srgbClr val="AEC1E6"/>
+                  <a:srgbClr val="AEC1E6">
+                    <a:alpha val="48000"/>
+                  </a:srgbClr>
                 </a:solidFill>
                 <a:latin typeface="Microsoft YaHei"/>
                 <a:ea typeface="Microsoft YaHei"/>
@@ -6760,10 +6762,10 @@
       </p:sp>
       <p:sp>
         <p:nvSpPr>
-          <p:cNvPr id="29" name="cycle-title-1">
+          <p:cNvPr id="28" name="cycle-title-1">
             <a:extLst xmlns:a="http://schemas.openxmlformats.org/drawingml/2006/main">
               <a:ext uri="{FF2B5EF4-FFF2-40B4-BE49-F238E27FC236}">
-                <a16:creationId xmlns:a16="http://schemas.microsoft.com/office/drawing/2014/main" id="{AB40537F-2AD3-41F1-AA95-1F44FD60BBB5}"/>
+                <a16:creationId xmlns:a16="http://schemas.microsoft.com/office/drawing/2014/main" id="{5EEADDF9-F19B-4E6B-B7DF-C97DF3397C36}"/>
               </a:ext>
             </a:extLst>
           </p:cNvPr>
@@ -6774,8 +6776,8 @@
         </p:nvSpPr>
         <p:spPr>
           <a:xfrm xmlns:a="http://schemas.openxmlformats.org/drawingml/2006/main" rot="2700000">
-            <a:off x="7104869" y="2507828"/>
-            <a:ext cx="542925" cy="285750"/>
+            <a:off x="7039108" y="2443029"/>
+            <a:ext cx="685800" cy="390525"/>
           </a:xfrm>
           <a:prstGeom xmlns:a="http://schemas.openxmlformats.org/drawingml/2006/main" prst="rect">
             <a:avLst/>
@@ -6787,13 +6789,17 @@
           </a:ln>
         </p:spPr>
         <p:txBody>
-          <a:bodyPr xmlns:a="http://schemas.openxmlformats.org/drawingml/2006/main" lIns="0" tIns="0" rIns="0" bIns="0" anchor="ctr">
-            <a:normAutofit fontScale="100000"/>
+          <a:bodyPr xmlns:a="http://schemas.openxmlformats.org/drawingml/2006/main" wrap="none" lIns="0" tIns="0" rIns="0" bIns="0" anchor="ctr">
+            <a:noAutofit/>
           </a:bodyPr>
           <a:lstStyle xmlns:a="http://schemas.openxmlformats.org/drawingml/2006/main"/>
           <a:p xmlns:a="http://schemas.openxmlformats.org/drawingml/2006/main">
             <a:pPr algn="ctr">
-              <a:defRPr sz="1500" b="0" i="0">
+              <a:lnSpc>
+                <a:spcPct val="100000"/>
+              </a:lnSpc>
+              <a:buNone/>
+              <a:defRPr sz="2100" b="0" i="0">
                 <a:solidFill>
                   <a:srgbClr val="FFD176"/>
                 </a:solidFill>
@@ -6803,7 +6809,7 @@
               </a:defRPr>
             </a:pPr>
             <a:r>
-              <a:rPr sz="1500" b="0" i="0">
+              <a:rPr sz="2100" b="0" i="0">
                 <a:solidFill>
                   <a:srgbClr val="FFD176"/>
                 </a:solidFill>
@@ -6818,10 +6824,10 @@
       </p:sp>
       <p:sp>
         <p:nvSpPr>
-          <p:cNvPr id="30" name="cycle-english-1">
+          <p:cNvPr id="29" name="cycle-number-2">
             <a:extLst xmlns:a="http://schemas.openxmlformats.org/drawingml/2006/main">
               <a:ext uri="{FF2B5EF4-FFF2-40B4-BE49-F238E27FC236}">
-                <a16:creationId xmlns:a16="http://schemas.microsoft.com/office/drawing/2014/main" id="{E65486F7-F249-4A9D-90A6-58EB86397C2A}"/>
+                <a16:creationId xmlns:a16="http://schemas.microsoft.com/office/drawing/2014/main" id="{071B1090-E084-4E9D-B918-348ACAC075AE}"/>
               </a:ext>
             </a:extLst>
           </p:cNvPr>
@@ -6831,9 +6837,9 @@
           <p:nvPr/>
         </p:nvSpPr>
         <p:spPr>
-          <a:xfrm xmlns:a="http://schemas.openxmlformats.org/drawingml/2006/main" rot="2700000">
-            <a:off x="6487116" y="3212316"/>
-            <a:ext cx="403469" cy="238277"/>
+          <a:xfrm xmlns:a="http://schemas.openxmlformats.org/drawingml/2006/main" rot="0">
+            <a:off x="6315275" y="5291995"/>
+            <a:ext cx="505568" cy="447675"/>
           </a:xfrm>
           <a:prstGeom xmlns:a="http://schemas.openxmlformats.org/drawingml/2006/main" prst="rect">
             <a:avLst/>
@@ -6845,15 +6851,21 @@
           </a:ln>
         </p:spPr>
         <p:txBody>
-          <a:bodyPr xmlns:a="http://schemas.openxmlformats.org/drawingml/2006/main" lIns="0" tIns="0" rIns="0" bIns="0" anchor="ctr">
-            <a:normAutofit fontScale="100000"/>
+          <a:bodyPr xmlns:a="http://schemas.openxmlformats.org/drawingml/2006/main" wrap="none" lIns="0" tIns="0" rIns="0" bIns="0" anchor="ctr">
+            <a:noAutofit/>
           </a:bodyPr>
           <a:lstStyle xmlns:a="http://schemas.openxmlformats.org/drawingml/2006/main"/>
           <a:p xmlns:a="http://schemas.openxmlformats.org/drawingml/2006/main">
             <a:pPr algn="ctr">
-              <a:defRPr sz="1200" b="0" i="0">
+              <a:lnSpc>
+                <a:spcPct val="100000"/>
+              </a:lnSpc>
+              <a:buNone/>
+              <a:defRPr sz="2500" b="0" i="0">
                 <a:solidFill>
-                  <a:srgbClr val="777777"/>
+                  <a:srgbClr val="AEC1E6">
+                    <a:alpha val="48000"/>
+                  </a:srgbClr>
                 </a:solidFill>
                 <a:latin typeface="Microsoft YaHei"/>
                 <a:ea typeface="Microsoft YaHei"/>
@@ -6861,67 +6873,11 @@
               </a:defRPr>
             </a:pPr>
             <a:r>
-              <a:rPr sz="1200" b="0" i="0">
+              <a:rPr sz="2500" b="0" i="0">
                 <a:solidFill>
-                  <a:srgbClr val="777777"/>
-                </a:solidFill>
-                <a:latin typeface="Microsoft YaHei"/>
-                <a:ea typeface="Microsoft YaHei"/>
-                <a:cs typeface="Microsoft YaHei"/>
-              </a:rPr>
-              <a:t>Do</a:t>
-            </a:r>
-          </a:p>
-        </p:txBody>
-      </p:sp>
-      <p:sp>
-        <p:nvSpPr>
-          <p:cNvPr id="31" name="cycle-number-2">
-            <a:extLst xmlns:a="http://schemas.openxmlformats.org/drawingml/2006/main">
-              <a:ext uri="{FF2B5EF4-FFF2-40B4-BE49-F238E27FC236}">
-                <a16:creationId xmlns:a16="http://schemas.microsoft.com/office/drawing/2014/main" id="{1DD501CD-58F7-4C0A-A4DC-965CB7A89F9C}"/>
-              </a:ext>
-            </a:extLst>
-          </p:cNvPr>
-          <p:cNvSpPr>
-            <a:spLocks xmlns:a="http://schemas.openxmlformats.org/drawingml/2006/main" noGrp="1"/>
-          </p:cNvSpPr>
-          <p:nvPr/>
-        </p:nvSpPr>
-        <p:spPr>
-          <a:xfrm xmlns:a="http://schemas.openxmlformats.org/drawingml/2006/main" rot="0">
-            <a:off x="6338192" y="5328456"/>
-            <a:ext cx="459734" cy="390525"/>
-          </a:xfrm>
-          <a:prstGeom xmlns:a="http://schemas.openxmlformats.org/drawingml/2006/main" prst="rect">
-            <a:avLst/>
-          </a:prstGeom>
-          <a:noFill xmlns:a="http://schemas.openxmlformats.org/drawingml/2006/main"/>
-          <a:ln xmlns:a="http://schemas.openxmlformats.org/drawingml/2006/main" w="0">
-            <a:noFill/>
-            <a:prstDash val="solid"/>
-          </a:ln>
-        </p:spPr>
-        <p:txBody>
-          <a:bodyPr xmlns:a="http://schemas.openxmlformats.org/drawingml/2006/main" lIns="0" tIns="0" rIns="0" bIns="0" anchor="ctr">
-            <a:normAutofit fontScale="100000"/>
-          </a:bodyPr>
-          <a:lstStyle xmlns:a="http://schemas.openxmlformats.org/drawingml/2006/main"/>
-          <a:p xmlns:a="http://schemas.openxmlformats.org/drawingml/2006/main">
-            <a:pPr algn="ctr">
-              <a:defRPr sz="2175" b="0" i="0">
-                <a:solidFill>
-                  <a:srgbClr val="AEC1E6"/>
-                </a:solidFill>
-                <a:latin typeface="Microsoft YaHei"/>
-                <a:ea typeface="Microsoft YaHei"/>
-                <a:cs typeface="Microsoft YaHei"/>
-              </a:defRPr>
-            </a:pPr>
-            <a:r>
-              <a:rPr sz="2175" b="0" i="0">
-                <a:solidFill>
-                  <a:srgbClr val="AEC1E6"/>
+                  <a:srgbClr val="AEC1E6">
+                    <a:alpha val="48000"/>
+                  </a:srgbClr>
                 </a:solidFill>
                 <a:latin typeface="Microsoft YaHei"/>
                 <a:ea typeface="Microsoft YaHei"/>
@@ -6934,10 +6890,10 @@
       </p:sp>
       <p:sp>
         <p:nvSpPr>
-          <p:cNvPr id="32" name="cycle-title-2">
+          <p:cNvPr id="30" name="cycle-title-2">
             <a:extLst xmlns:a="http://schemas.openxmlformats.org/drawingml/2006/main">
               <a:ext uri="{FF2B5EF4-FFF2-40B4-BE49-F238E27FC236}">
-                <a16:creationId xmlns:a16="http://schemas.microsoft.com/office/drawing/2014/main" id="{869731C2-DDDB-4F41-8EF8-9073F2DB5B3E}"/>
+                <a16:creationId xmlns:a16="http://schemas.microsoft.com/office/drawing/2014/main" id="{6E84C5D3-1728-44EA-AA2D-EADC8314AB3A}"/>
               </a:ext>
             </a:extLst>
           </p:cNvPr>
@@ -6948,8 +6904,8 @@
         </p:nvSpPr>
         <p:spPr>
           <a:xfrm xmlns:a="http://schemas.openxmlformats.org/drawingml/2006/main" rot="8100000">
-            <a:off x="7096735" y="5058385"/>
-            <a:ext cx="552450" cy="285750"/>
+            <a:off x="7039108" y="5015046"/>
+            <a:ext cx="685800" cy="390525"/>
           </a:xfrm>
           <a:prstGeom xmlns:a="http://schemas.openxmlformats.org/drawingml/2006/main" prst="rect">
             <a:avLst/>
@@ -6961,13 +6917,17 @@
           </a:ln>
         </p:spPr>
         <p:txBody>
-          <a:bodyPr xmlns:a="http://schemas.openxmlformats.org/drawingml/2006/main" lIns="0" tIns="0" rIns="0" bIns="0" anchor="ctr">
-            <a:normAutofit fontScale="100000"/>
+          <a:bodyPr xmlns:a="http://schemas.openxmlformats.org/drawingml/2006/main" wrap="none" lIns="0" tIns="0" rIns="0" bIns="0" anchor="ctr">
+            <a:noAutofit/>
           </a:bodyPr>
           <a:lstStyle xmlns:a="http://schemas.openxmlformats.org/drawingml/2006/main"/>
           <a:p xmlns:a="http://schemas.openxmlformats.org/drawingml/2006/main">
             <a:pPr algn="ctr">
-              <a:defRPr sz="1500" b="0" i="0">
+              <a:lnSpc>
+                <a:spcPct val="100000"/>
+              </a:lnSpc>
+              <a:buNone/>
+              <a:defRPr sz="2100" b="0" i="0">
                 <a:solidFill>
                   <a:srgbClr val="FFD176"/>
                 </a:solidFill>
@@ -6977,7 +6937,7 @@
               </a:defRPr>
             </a:pPr>
             <a:r>
-              <a:rPr sz="1500" b="0" i="0">
+              <a:rPr sz="2100" b="0" i="0">
                 <a:solidFill>
                   <a:srgbClr val="FFD176"/>
                 </a:solidFill>
@@ -6992,10 +6952,10 @@
       </p:sp>
       <p:sp>
         <p:nvSpPr>
-          <p:cNvPr id="33" name="cycle-english-2">
+          <p:cNvPr id="31" name="cycle-number-3">
             <a:extLst xmlns:a="http://schemas.openxmlformats.org/drawingml/2006/main">
               <a:ext uri="{FF2B5EF4-FFF2-40B4-BE49-F238E27FC236}">
-                <a16:creationId xmlns:a16="http://schemas.microsoft.com/office/drawing/2014/main" id="{35146F36-903D-4AEF-B6FC-C01A6652695E}"/>
+                <a16:creationId xmlns:a16="http://schemas.microsoft.com/office/drawing/2014/main" id="{7D8526EC-CA7F-4FA5-AB28-8168B11715E8}"/>
               </a:ext>
             </a:extLst>
           </p:cNvPr>
@@ -7005,9 +6965,9 @@
           <p:nvPr/>
         </p:nvSpPr>
         <p:spPr>
-          <a:xfrm xmlns:a="http://schemas.openxmlformats.org/drawingml/2006/main" rot="8100000">
-            <a:off x="6344164" y="4398007"/>
-            <a:ext cx="689372" cy="238277"/>
+          <a:xfrm xmlns:a="http://schemas.openxmlformats.org/drawingml/2006/main" rot="0">
+            <a:off x="4215594" y="4139184"/>
+            <a:ext cx="511073" cy="447675"/>
           </a:xfrm>
           <a:prstGeom xmlns:a="http://schemas.openxmlformats.org/drawingml/2006/main" prst="rect">
             <a:avLst/>
@@ -7019,15 +6979,21 @@
           </a:ln>
         </p:spPr>
         <p:txBody>
-          <a:bodyPr xmlns:a="http://schemas.openxmlformats.org/drawingml/2006/main" lIns="0" tIns="0" rIns="0" bIns="0" anchor="ctr">
-            <a:normAutofit fontScale="100000"/>
+          <a:bodyPr xmlns:a="http://schemas.openxmlformats.org/drawingml/2006/main" wrap="none" lIns="0" tIns="0" rIns="0" bIns="0" anchor="ctr">
+            <a:noAutofit/>
           </a:bodyPr>
           <a:lstStyle xmlns:a="http://schemas.openxmlformats.org/drawingml/2006/main"/>
           <a:p xmlns:a="http://schemas.openxmlformats.org/drawingml/2006/main">
             <a:pPr algn="ctr">
-              <a:defRPr sz="1200" b="0" i="0">
+              <a:lnSpc>
+                <a:spcPct val="100000"/>
+              </a:lnSpc>
+              <a:buNone/>
+              <a:defRPr sz="2500" b="0" i="0">
                 <a:solidFill>
-                  <a:srgbClr val="777777"/>
+                  <a:srgbClr val="AEC1E6">
+                    <a:alpha val="48000"/>
+                  </a:srgbClr>
                 </a:solidFill>
                 <a:latin typeface="Microsoft YaHei"/>
                 <a:ea typeface="Microsoft YaHei"/>
@@ -7035,67 +7001,11 @@
               </a:defRPr>
             </a:pPr>
             <a:r>
-              <a:rPr sz="1200" b="0" i="0">
+              <a:rPr sz="2500" b="0" i="0">
                 <a:solidFill>
-                  <a:srgbClr val="777777"/>
-                </a:solidFill>
-                <a:latin typeface="Microsoft YaHei"/>
-                <a:ea typeface="Microsoft YaHei"/>
-                <a:cs typeface="Microsoft YaHei"/>
-              </a:rPr>
-              <a:t>Check</a:t>
-            </a:r>
-          </a:p>
-        </p:txBody>
-      </p:sp>
-      <p:sp>
-        <p:nvSpPr>
-          <p:cNvPr id="34" name="cycle-number-3">
-            <a:extLst xmlns:a="http://schemas.openxmlformats.org/drawingml/2006/main">
-              <a:ext uri="{FF2B5EF4-FFF2-40B4-BE49-F238E27FC236}">
-                <a16:creationId xmlns:a16="http://schemas.microsoft.com/office/drawing/2014/main" id="{AB97546D-19C3-494C-B6F4-854D9617B51B}"/>
-              </a:ext>
-            </a:extLst>
-          </p:cNvPr>
-          <p:cNvSpPr>
-            <a:spLocks xmlns:a="http://schemas.openxmlformats.org/drawingml/2006/main" noGrp="1"/>
-          </p:cNvSpPr>
-          <p:nvPr/>
-        </p:nvSpPr>
-        <p:spPr>
-          <a:xfrm xmlns:a="http://schemas.openxmlformats.org/drawingml/2006/main" rot="0">
-            <a:off x="4238882" y="4175646"/>
-            <a:ext cx="467944" cy="390525"/>
-          </a:xfrm>
-          <a:prstGeom xmlns:a="http://schemas.openxmlformats.org/drawingml/2006/main" prst="rect">
-            <a:avLst/>
-          </a:prstGeom>
-          <a:noFill xmlns:a="http://schemas.openxmlformats.org/drawingml/2006/main"/>
-          <a:ln xmlns:a="http://schemas.openxmlformats.org/drawingml/2006/main" w="0">
-            <a:noFill/>
-            <a:prstDash val="solid"/>
-          </a:ln>
-        </p:spPr>
-        <p:txBody>
-          <a:bodyPr xmlns:a="http://schemas.openxmlformats.org/drawingml/2006/main" lIns="0" tIns="0" rIns="0" bIns="0" anchor="ctr">
-            <a:normAutofit fontScale="100000"/>
-          </a:bodyPr>
-          <a:lstStyle xmlns:a="http://schemas.openxmlformats.org/drawingml/2006/main"/>
-          <a:p xmlns:a="http://schemas.openxmlformats.org/drawingml/2006/main">
-            <a:pPr algn="ctr">
-              <a:defRPr sz="2175" b="0" i="0">
-                <a:solidFill>
-                  <a:srgbClr val="AEC1E6"/>
-                </a:solidFill>
-                <a:latin typeface="Microsoft YaHei"/>
-                <a:ea typeface="Microsoft YaHei"/>
-                <a:cs typeface="Microsoft YaHei"/>
-              </a:defRPr>
-            </a:pPr>
-            <a:r>
-              <a:rPr sz="2175" b="0" i="0">
-                <a:solidFill>
-                  <a:srgbClr val="AEC1E6"/>
+                  <a:srgbClr val="AEC1E6">
+                    <a:alpha val="48000"/>
+                  </a:srgbClr>
                 </a:solidFill>
                 <a:latin typeface="Microsoft YaHei"/>
                 <a:ea typeface="Microsoft YaHei"/>
@@ -7108,10 +7018,10 @@
       </p:sp>
       <p:sp>
         <p:nvSpPr>
-          <p:cNvPr id="35" name="cycle-title-3">
+          <p:cNvPr id="32" name="cycle-title-3">
             <a:extLst xmlns:a="http://schemas.openxmlformats.org/drawingml/2006/main">
               <a:ext uri="{FF2B5EF4-FFF2-40B4-BE49-F238E27FC236}">
-                <a16:creationId xmlns:a16="http://schemas.microsoft.com/office/drawing/2014/main" id="{BCF65955-88DA-4A35-9929-19B2D0A0705C}"/>
+                <a16:creationId xmlns:a16="http://schemas.microsoft.com/office/drawing/2014/main" id="{BDB18D5E-810C-499A-A7ED-F914B4245A18}"/>
               </a:ext>
             </a:extLst>
           </p:cNvPr>
@@ -7122,8 +7032,8 @@
         </p:nvSpPr>
         <p:spPr>
           <a:xfrm xmlns:a="http://schemas.openxmlformats.org/drawingml/2006/main" rot="-8100000">
-            <a:off x="4552340" y="5058385"/>
-            <a:ext cx="533400" cy="285750"/>
+            <a:off x="4467092" y="5015046"/>
+            <a:ext cx="685800" cy="390525"/>
           </a:xfrm>
           <a:prstGeom xmlns:a="http://schemas.openxmlformats.org/drawingml/2006/main" prst="rect">
             <a:avLst/>
@@ -7135,13 +7045,17 @@
           </a:ln>
         </p:spPr>
         <p:txBody>
-          <a:bodyPr xmlns:a="http://schemas.openxmlformats.org/drawingml/2006/main" lIns="0" tIns="0" rIns="0" bIns="0" anchor="ctr">
-            <a:normAutofit fontScale="100000"/>
+          <a:bodyPr xmlns:a="http://schemas.openxmlformats.org/drawingml/2006/main" wrap="none" lIns="0" tIns="0" rIns="0" bIns="0" anchor="ctr">
+            <a:noAutofit/>
           </a:bodyPr>
           <a:lstStyle xmlns:a="http://schemas.openxmlformats.org/drawingml/2006/main"/>
           <a:p xmlns:a="http://schemas.openxmlformats.org/drawingml/2006/main">
             <a:pPr algn="ctr">
-              <a:defRPr sz="1500" b="0" i="0">
+              <a:lnSpc>
+                <a:spcPct val="100000"/>
+              </a:lnSpc>
+              <a:buNone/>
+              <a:defRPr sz="2100" b="0" i="0">
                 <a:solidFill>
                   <a:srgbClr val="FFD176"/>
                 </a:solidFill>
@@ -7151,7 +7065,7 @@
               </a:defRPr>
             </a:pPr>
             <a:r>
-              <a:rPr sz="1500" b="0" i="0">
+              <a:rPr sz="2100" b="0" i="0">
                 <a:solidFill>
                   <a:srgbClr val="FFD176"/>
                 </a:solidFill>
@@ -7166,68 +7080,10 @@
       </p:sp>
       <p:sp>
         <p:nvSpPr>
-          <p:cNvPr id="36" name="cycle-english-3">
+          <p:cNvPr id="33" name="cycle-core">
             <a:extLst xmlns:a="http://schemas.openxmlformats.org/drawingml/2006/main">
               <a:ext uri="{FF2B5EF4-FFF2-40B4-BE49-F238E27FC236}">
-                <a16:creationId xmlns:a16="http://schemas.microsoft.com/office/drawing/2014/main" id="{D531A610-28CE-41BD-B118-76070732787C}"/>
-              </a:ext>
-            </a:extLst>
-          </p:cNvPr>
-          <p:cNvSpPr>
-            <a:spLocks xmlns:a="http://schemas.openxmlformats.org/drawingml/2006/main" noGrp="1"/>
-          </p:cNvSpPr>
-          <p:nvPr/>
-        </p:nvSpPr>
-        <p:spPr>
-          <a:xfrm xmlns:a="http://schemas.openxmlformats.org/drawingml/2006/main" rot="-8100000">
-            <a:off x="5276726" y="4401379"/>
-            <a:ext cx="459581" cy="238277"/>
-          </a:xfrm>
-          <a:prstGeom xmlns:a="http://schemas.openxmlformats.org/drawingml/2006/main" prst="rect">
-            <a:avLst/>
-          </a:prstGeom>
-          <a:noFill xmlns:a="http://schemas.openxmlformats.org/drawingml/2006/main"/>
-          <a:ln xmlns:a="http://schemas.openxmlformats.org/drawingml/2006/main" w="0">
-            <a:noFill/>
-            <a:prstDash val="solid"/>
-          </a:ln>
-        </p:spPr>
-        <p:txBody>
-          <a:bodyPr xmlns:a="http://schemas.openxmlformats.org/drawingml/2006/main" lIns="0" tIns="0" rIns="0" bIns="0" anchor="ctr">
-            <a:normAutofit fontScale="100000"/>
-          </a:bodyPr>
-          <a:lstStyle xmlns:a="http://schemas.openxmlformats.org/drawingml/2006/main"/>
-          <a:p xmlns:a="http://schemas.openxmlformats.org/drawingml/2006/main">
-            <a:pPr algn="ctr">
-              <a:defRPr sz="1200" b="0" i="0">
-                <a:solidFill>
-                  <a:srgbClr val="777777"/>
-                </a:solidFill>
-                <a:latin typeface="Microsoft YaHei"/>
-                <a:ea typeface="Microsoft YaHei"/>
-                <a:cs typeface="Microsoft YaHei"/>
-              </a:defRPr>
-            </a:pPr>
-            <a:r>
-              <a:rPr sz="1200" b="0" i="0">
-                <a:solidFill>
-                  <a:srgbClr val="777777"/>
-                </a:solidFill>
-                <a:latin typeface="Microsoft YaHei"/>
-                <a:ea typeface="Microsoft YaHei"/>
-                <a:cs typeface="Microsoft YaHei"/>
-              </a:rPr>
-              <a:t>Act</a:t>
-            </a:r>
-          </a:p>
-        </p:txBody>
-      </p:sp>
-      <p:sp>
-        <p:nvSpPr>
-          <p:cNvPr id="37" name="cycle-core">
-            <a:extLst xmlns:a="http://schemas.openxmlformats.org/drawingml/2006/main">
-              <a:ext uri="{FF2B5EF4-FFF2-40B4-BE49-F238E27FC236}">
-                <a16:creationId xmlns:a16="http://schemas.microsoft.com/office/drawing/2014/main" id="{AB76D532-8998-4EAF-94E0-12EACB14BFF4}"/>
+                <a16:creationId xmlns:a16="http://schemas.microsoft.com/office/drawing/2014/main" id="{A8ED41DF-87A0-4312-BF5C-D3B25EC0C861}"/>
               </a:ext>
             </a:extLst>
           </p:cNvPr>
@@ -7257,10 +7113,10 @@
       </p:sp>
       <p:sp>
         <p:nvSpPr>
-          <p:cNvPr id="38" name="cycle-core-text-0">
+          <p:cNvPr id="34" name="cycle-core-text-0">
             <a:extLst xmlns:a="http://schemas.openxmlformats.org/drawingml/2006/main">
               <a:ext uri="{FF2B5EF4-FFF2-40B4-BE49-F238E27FC236}">
-                <a16:creationId xmlns:a16="http://schemas.microsoft.com/office/drawing/2014/main" id="{35E3F4EA-8003-44CF-B861-4486734CD9E4}"/>
+                <a16:creationId xmlns:a16="http://schemas.microsoft.com/office/drawing/2014/main" id="{4BD8B7B1-D20E-46BC-B10C-36AE971667F7}"/>
               </a:ext>
             </a:extLst>
           </p:cNvPr>
@@ -7271,8 +7127,8 @@
         </p:nvSpPr>
         <p:spPr>
           <a:xfrm xmlns:a="http://schemas.openxmlformats.org/drawingml/2006/main" rot="0">
-            <a:off x="5718943" y="3630959"/>
-            <a:ext cx="761781" cy="323850"/>
+            <a:off x="5618778" y="3574552"/>
+            <a:ext cx="958425" cy="419100"/>
           </a:xfrm>
           <a:prstGeom xmlns:a="http://schemas.openxmlformats.org/drawingml/2006/main" prst="rect">
             <a:avLst/>
@@ -7284,13 +7140,17 @@
           </a:ln>
         </p:spPr>
         <p:txBody>
-          <a:bodyPr xmlns:a="http://schemas.openxmlformats.org/drawingml/2006/main" lIns="0" tIns="0" rIns="0" bIns="0" anchor="ctr">
-            <a:normAutofit fontScale="100000"/>
+          <a:bodyPr xmlns:a="http://schemas.openxmlformats.org/drawingml/2006/main" wrap="none" lIns="0" tIns="0" rIns="0" bIns="0" anchor="ctr">
+            <a:noAutofit/>
           </a:bodyPr>
           <a:lstStyle xmlns:a="http://schemas.openxmlformats.org/drawingml/2006/main"/>
           <a:p xmlns:a="http://schemas.openxmlformats.org/drawingml/2006/main">
             <a:pPr algn="ctr">
-              <a:defRPr sz="1725" b="0" i="0">
+              <a:lnSpc>
+                <a:spcPct val="100000"/>
+              </a:lnSpc>
+              <a:buNone/>
+              <a:defRPr sz="2300" b="0" i="0">
                 <a:solidFill>
                   <a:srgbClr val="444444"/>
                 </a:solidFill>
@@ -7300,7 +7160,7 @@
               </a:defRPr>
             </a:pPr>
             <a:r>
-              <a:rPr sz="1725" b="0" i="0">
+              <a:rPr sz="2300" b="0" i="0">
                 <a:solidFill>
                   <a:srgbClr val="444444"/>
                 </a:solidFill>
@@ -7315,10 +7175,10 @@
       </p:sp>
       <p:sp>
         <p:nvSpPr>
-          <p:cNvPr id="39" name="cycle-core-text-1">
+          <p:cNvPr id="35" name="cycle-core-text-1">
             <a:extLst xmlns:a="http://schemas.openxmlformats.org/drawingml/2006/main">
               <a:ext uri="{FF2B5EF4-FFF2-40B4-BE49-F238E27FC236}">
-                <a16:creationId xmlns:a16="http://schemas.microsoft.com/office/drawing/2014/main" id="{A7220BEE-994E-4DF9-B43D-8D676222CAAC}"/>
+                <a16:creationId xmlns:a16="http://schemas.microsoft.com/office/drawing/2014/main" id="{E64EFFAD-1D61-4200-9669-696DBFC358DF}"/>
               </a:ext>
             </a:extLst>
           </p:cNvPr>
@@ -7329,8 +7189,8 @@
         </p:nvSpPr>
         <p:spPr>
           <a:xfrm xmlns:a="http://schemas.openxmlformats.org/drawingml/2006/main" rot="0">
-            <a:off x="5800725" y="3964334"/>
-            <a:ext cx="590550" cy="323850"/>
+            <a:off x="5727725" y="3907927"/>
+            <a:ext cx="739712" cy="419100"/>
           </a:xfrm>
           <a:prstGeom xmlns:a="http://schemas.openxmlformats.org/drawingml/2006/main" prst="rect">
             <a:avLst/>
@@ -7342,13 +7202,17 @@
           </a:ln>
         </p:spPr>
         <p:txBody>
-          <a:bodyPr xmlns:a="http://schemas.openxmlformats.org/drawingml/2006/main" lIns="0" tIns="0" rIns="0" bIns="0" anchor="ctr">
-            <a:normAutofit fontScale="100000"/>
+          <a:bodyPr xmlns:a="http://schemas.openxmlformats.org/drawingml/2006/main" wrap="none" lIns="0" tIns="0" rIns="0" bIns="0" anchor="ctr">
+            <a:noAutofit/>
           </a:bodyPr>
           <a:lstStyle xmlns:a="http://schemas.openxmlformats.org/drawingml/2006/main"/>
           <a:p xmlns:a="http://schemas.openxmlformats.org/drawingml/2006/main">
             <a:pPr algn="ctr">
-              <a:defRPr sz="1725" b="0" i="0">
+              <a:lnSpc>
+                <a:spcPct val="100000"/>
+              </a:lnSpc>
+              <a:buNone/>
+              <a:defRPr sz="2300" b="0" i="0">
                 <a:solidFill>
                   <a:srgbClr val="444444"/>
                 </a:solidFill>
@@ -7358,7 +7222,7 @@
               </a:defRPr>
             </a:pPr>
             <a:r>
-              <a:rPr sz="1725" b="0" i="0">
+              <a:rPr sz="2300" b="0" i="0">
                 <a:solidFill>
                   <a:srgbClr val="444444"/>
                 </a:solidFill>
@@ -7374,7 +7238,7 @@
     </p:spTree>
     <p:extLst>
       <p:ext uri="{BB962C8B-B14F-4D97-AF65-F5344CB8AC3E}">
-        <p14:creationId xmlns:p14="http://schemas.microsoft.com/office/powerpoint/2010/main" val="1030126228"/>
+        <p14:creationId xmlns:p14="http://schemas.microsoft.com/office/powerpoint/2010/main" val="1781344967"/>
       </p:ext>
     </p:extLst>
   </p:cSld>

</xml_diff>